<commit_message>
Update with course material from induction lecture.
Signed-off-by: Charlie Murphy <tm507211@ohio.edu>
</commit_message>
<xml_diff>
--- a/courses/csci246/spring26/slides/02_27_26_smallest_counterexample.pptx
+++ b/courses/csci246/spring26/slides/02_27_26_smallest_counterexample.pptx
@@ -4010,8 +4010,8 @@
           </a:p>
         </p:txBody>
       </p:sp>
-      <mc:AlternateContent xmlns:mc="http://schemas.openxmlformats.org/markup-compatibility/2006">
-        <mc:Choice xmlns:a14="http://schemas.microsoft.com/office/drawing/2010/main" Requires="a14">
+      <mc:AlternateContent xmlns:mc="http://schemas.openxmlformats.org/markup-compatibility/2006" xmlns:a14="http://schemas.microsoft.com/office/drawing/2010/main">
+        <mc:Choice Requires="a14">
           <p:sp>
             <p:nvSpPr>
               <p:cNvPr id="3" name="Content Placeholder 14">
@@ -4158,7 +4158,7 @@
             </p:txBody>
           </p:sp>
         </mc:Choice>
-        <mc:Fallback>
+        <mc:Fallback xmlns="">
           <p:sp>
             <p:nvSpPr>
               <p:cNvPr id="3" name="Content Placeholder 14">
@@ -4202,8 +4202,8 @@
           </p:sp>
         </mc:Fallback>
       </mc:AlternateContent>
-      <mc:AlternateContent xmlns:mc="http://schemas.openxmlformats.org/markup-compatibility/2006">
-        <mc:Choice xmlns:a14="http://schemas.microsoft.com/office/drawing/2010/main" Requires="a14">
+      <mc:AlternateContent xmlns:mc="http://schemas.openxmlformats.org/markup-compatibility/2006" xmlns:a14="http://schemas.microsoft.com/office/drawing/2010/main">
+        <mc:Choice Requires="a14">
           <p:sp>
             <p:nvSpPr>
               <p:cNvPr id="4" name="TextBox 3">
@@ -4232,6 +4232,7 @@
               </a:bodyPr>
               <a:lstStyle/>
               <a:p>
+                <a:pPr/>
                 <a14:m>
                   <m:oMathPara xmlns:m="http://schemas.openxmlformats.org/officeDocument/2006/math">
                     <m:oMathParaPr>
@@ -4252,7 +4253,7 @@
             </p:txBody>
           </p:sp>
         </mc:Choice>
-        <mc:Fallback>
+        <mc:Fallback xmlns="">
           <p:sp>
             <p:nvSpPr>
               <p:cNvPr id="4" name="TextBox 3">
@@ -4297,8 +4298,8 @@
           </p:sp>
         </mc:Fallback>
       </mc:AlternateContent>
-      <mc:AlternateContent xmlns:mc="http://schemas.openxmlformats.org/markup-compatibility/2006">
-        <mc:Choice xmlns:a14="http://schemas.microsoft.com/office/drawing/2010/main" Requires="a14">
+      <mc:AlternateContent xmlns:mc="http://schemas.openxmlformats.org/markup-compatibility/2006" xmlns:a14="http://schemas.microsoft.com/office/drawing/2010/main">
+        <mc:Choice Requires="a14">
           <p:sp>
             <p:nvSpPr>
               <p:cNvPr id="5" name="TextBox 4">
@@ -4327,6 +4328,7 @@
               </a:bodyPr>
               <a:lstStyle/>
               <a:p>
+                <a:pPr/>
                 <a14:m>
                   <m:oMathPara xmlns:m="http://schemas.openxmlformats.org/officeDocument/2006/math">
                     <m:oMathParaPr>
@@ -4347,7 +4349,7 @@
             </p:txBody>
           </p:sp>
         </mc:Choice>
-        <mc:Fallback>
+        <mc:Fallback xmlns="">
           <p:sp>
             <p:nvSpPr>
               <p:cNvPr id="5" name="TextBox 4">
@@ -4392,8 +4394,8 @@
           </p:sp>
         </mc:Fallback>
       </mc:AlternateContent>
-      <mc:AlternateContent xmlns:mc="http://schemas.openxmlformats.org/markup-compatibility/2006">
-        <mc:Choice xmlns:a14="http://schemas.microsoft.com/office/drawing/2010/main" Requires="a14">
+      <mc:AlternateContent xmlns:mc="http://schemas.openxmlformats.org/markup-compatibility/2006" xmlns:a14="http://schemas.microsoft.com/office/drawing/2010/main">
+        <mc:Choice Requires="a14">
           <p:sp>
             <p:nvSpPr>
               <p:cNvPr id="9" name="TextBox 8">
@@ -4422,6 +4424,7 @@
               </a:bodyPr>
               <a:lstStyle/>
               <a:p>
+                <a:pPr/>
                 <a14:m>
                   <m:oMathPara xmlns:m="http://schemas.openxmlformats.org/officeDocument/2006/math">
                     <m:oMathParaPr>
@@ -4442,7 +4445,7 @@
             </p:txBody>
           </p:sp>
         </mc:Choice>
-        <mc:Fallback>
+        <mc:Fallback xmlns="">
           <p:sp>
             <p:nvSpPr>
               <p:cNvPr id="9" name="TextBox 8">
@@ -4487,8 +4490,8 @@
           </p:sp>
         </mc:Fallback>
       </mc:AlternateContent>
-      <mc:AlternateContent xmlns:mc="http://schemas.openxmlformats.org/markup-compatibility/2006">
-        <mc:Choice xmlns:a14="http://schemas.microsoft.com/office/drawing/2010/main" Requires="a14">
+      <mc:AlternateContent xmlns:mc="http://schemas.openxmlformats.org/markup-compatibility/2006" xmlns:a14="http://schemas.microsoft.com/office/drawing/2010/main">
+        <mc:Choice Requires="a14">
           <p:sp>
             <p:nvSpPr>
               <p:cNvPr id="11" name="TextBox 10">
@@ -4517,6 +4520,7 @@
               </a:bodyPr>
               <a:lstStyle/>
               <a:p>
+                <a:pPr/>
                 <a14:m>
                   <m:oMathPara xmlns:m="http://schemas.openxmlformats.org/officeDocument/2006/math">
                     <m:oMathParaPr>
@@ -4538,7 +4542,7 @@
             </p:txBody>
           </p:sp>
         </mc:Choice>
-        <mc:Fallback>
+        <mc:Fallback xmlns="">
           <p:sp>
             <p:nvSpPr>
               <p:cNvPr id="11" name="TextBox 10">
@@ -4824,8 +4828,8 @@
           </a:p>
         </p:txBody>
       </p:sp>
-      <mc:AlternateContent xmlns:mc="http://schemas.openxmlformats.org/markup-compatibility/2006">
-        <mc:Choice xmlns:a14="http://schemas.microsoft.com/office/drawing/2010/main" Requires="a14">
+      <mc:AlternateContent xmlns:mc="http://schemas.openxmlformats.org/markup-compatibility/2006" xmlns:a14="http://schemas.microsoft.com/office/drawing/2010/main">
+        <mc:Choice Requires="a14">
           <p:sp>
             <p:nvSpPr>
               <p:cNvPr id="3" name="Content Placeholder 14">
@@ -5049,7 +5053,7 @@
             </p:txBody>
           </p:sp>
         </mc:Choice>
-        <mc:Fallback>
+        <mc:Fallback xmlns="">
           <p:sp>
             <p:nvSpPr>
               <p:cNvPr id="3" name="Content Placeholder 14">
@@ -5181,8 +5185,8 @@
           </a:p>
         </p:txBody>
       </p:sp>
-      <mc:AlternateContent xmlns:mc="http://schemas.openxmlformats.org/markup-compatibility/2006">
-        <mc:Choice xmlns:a14="http://schemas.microsoft.com/office/drawing/2010/main" Requires="a14">
+      <mc:AlternateContent xmlns:mc="http://schemas.openxmlformats.org/markup-compatibility/2006" xmlns:a14="http://schemas.microsoft.com/office/drawing/2010/main">
+        <mc:Choice Requires="a14">
           <p:sp>
             <p:nvSpPr>
               <p:cNvPr id="16" name="TextBox 15">
@@ -5211,6 +5215,7 @@
               </a:bodyPr>
               <a:lstStyle/>
               <a:p>
+                <a:pPr/>
                 <a14:m>
                   <m:oMathPara xmlns:m="http://schemas.openxmlformats.org/officeDocument/2006/math">
                     <m:oMathParaPr>
@@ -5250,7 +5255,7 @@
             </p:txBody>
           </p:sp>
         </mc:Choice>
-        <mc:Fallback>
+        <mc:Fallback xmlns="">
           <p:sp>
             <p:nvSpPr>
               <p:cNvPr id="16" name="TextBox 15">
@@ -5295,8 +5300,8 @@
           </p:sp>
         </mc:Fallback>
       </mc:AlternateContent>
-      <mc:AlternateContent xmlns:mc="http://schemas.openxmlformats.org/markup-compatibility/2006">
-        <mc:Choice xmlns:a14="http://schemas.microsoft.com/office/drawing/2010/main" Requires="a14">
+      <mc:AlternateContent xmlns:mc="http://schemas.openxmlformats.org/markup-compatibility/2006" xmlns:a14="http://schemas.microsoft.com/office/drawing/2010/main">
+        <mc:Choice Requires="a14">
           <p:sp>
             <p:nvSpPr>
               <p:cNvPr id="17" name="TextBox 16">
@@ -5325,6 +5330,7 @@
               </a:bodyPr>
               <a:lstStyle/>
               <a:p>
+                <a:pPr/>
                 <a14:m>
                   <m:oMathPara xmlns:m="http://schemas.openxmlformats.org/officeDocument/2006/math">
                     <m:oMathParaPr>
@@ -5345,7 +5351,7 @@
             </p:txBody>
           </p:sp>
         </mc:Choice>
-        <mc:Fallback>
+        <mc:Fallback xmlns="">
           <p:sp>
             <p:nvSpPr>
               <p:cNvPr id="17" name="TextBox 16">
@@ -5390,8 +5396,8 @@
           </p:sp>
         </mc:Fallback>
       </mc:AlternateContent>
-      <mc:AlternateContent xmlns:mc="http://schemas.openxmlformats.org/markup-compatibility/2006">
-        <mc:Choice xmlns:a14="http://schemas.microsoft.com/office/drawing/2010/main" Requires="a14">
+      <mc:AlternateContent xmlns:mc="http://schemas.openxmlformats.org/markup-compatibility/2006" xmlns:a14="http://schemas.microsoft.com/office/drawing/2010/main">
+        <mc:Choice Requires="a14">
           <p:sp>
             <p:nvSpPr>
               <p:cNvPr id="18" name="TextBox 17">
@@ -5420,6 +5426,7 @@
               </a:bodyPr>
               <a:lstStyle/>
               <a:p>
+                <a:pPr/>
                 <a14:m>
                   <m:oMathPara xmlns:m="http://schemas.openxmlformats.org/officeDocument/2006/math">
                     <m:oMathParaPr>
@@ -5440,7 +5447,7 @@
             </p:txBody>
           </p:sp>
         </mc:Choice>
-        <mc:Fallback>
+        <mc:Fallback xmlns="">
           <p:sp>
             <p:nvSpPr>
               <p:cNvPr id="18" name="TextBox 17">
@@ -5485,8 +5492,8 @@
           </p:sp>
         </mc:Fallback>
       </mc:AlternateContent>
-      <mc:AlternateContent xmlns:mc="http://schemas.openxmlformats.org/markup-compatibility/2006">
-        <mc:Choice xmlns:a14="http://schemas.microsoft.com/office/drawing/2010/main" Requires="a14">
+      <mc:AlternateContent xmlns:mc="http://schemas.openxmlformats.org/markup-compatibility/2006" xmlns:a14="http://schemas.microsoft.com/office/drawing/2010/main">
+        <mc:Choice Requires="a14">
           <p:sp>
             <p:nvSpPr>
               <p:cNvPr id="19" name="TextBox 18">
@@ -5515,6 +5522,7 @@
               </a:bodyPr>
               <a:lstStyle/>
               <a:p>
+                <a:pPr/>
                 <a14:m>
                   <m:oMathPara xmlns:m="http://schemas.openxmlformats.org/officeDocument/2006/math">
                     <m:oMathParaPr>
@@ -5535,7 +5543,7 @@
             </p:txBody>
           </p:sp>
         </mc:Choice>
-        <mc:Fallback>
+        <mc:Fallback xmlns="">
           <p:sp>
             <p:nvSpPr>
               <p:cNvPr id="19" name="TextBox 18">
@@ -5580,8 +5588,8 @@
           </p:sp>
         </mc:Fallback>
       </mc:AlternateContent>
-      <mc:AlternateContent xmlns:mc="http://schemas.openxmlformats.org/markup-compatibility/2006">
-        <mc:Choice xmlns:a14="http://schemas.microsoft.com/office/drawing/2010/main" Requires="a14">
+      <mc:AlternateContent xmlns:mc="http://schemas.openxmlformats.org/markup-compatibility/2006" xmlns:a14="http://schemas.microsoft.com/office/drawing/2010/main">
+        <mc:Choice Requires="a14">
           <p:sp>
             <p:nvSpPr>
               <p:cNvPr id="20" name="TextBox 19">
@@ -5610,6 +5618,7 @@
               </a:bodyPr>
               <a:lstStyle/>
               <a:p>
+                <a:pPr/>
                 <a14:m>
                   <m:oMathPara xmlns:m="http://schemas.openxmlformats.org/officeDocument/2006/math">
                     <m:oMathParaPr>
@@ -5631,7 +5640,7 @@
             </p:txBody>
           </p:sp>
         </mc:Choice>
-        <mc:Fallback>
+        <mc:Fallback xmlns="">
           <p:sp>
             <p:nvSpPr>
               <p:cNvPr id="20" name="TextBox 19">
@@ -6019,8 +6028,8 @@
           </a:p>
         </p:txBody>
       </p:sp>
-      <mc:AlternateContent xmlns:mc="http://schemas.openxmlformats.org/markup-compatibility/2006">
-        <mc:Choice xmlns:a14="http://schemas.microsoft.com/office/drawing/2010/main" Requires="a14">
+      <mc:AlternateContent xmlns:mc="http://schemas.openxmlformats.org/markup-compatibility/2006" xmlns:a14="http://schemas.microsoft.com/office/drawing/2010/main">
+        <mc:Choice Requires="a14">
           <p:sp>
             <p:nvSpPr>
               <p:cNvPr id="3" name="Content Placeholder 14">
@@ -6261,7 +6270,7 @@
             </p:txBody>
           </p:sp>
         </mc:Choice>
-        <mc:Fallback>
+        <mc:Fallback xmlns="">
           <p:sp>
             <p:nvSpPr>
               <p:cNvPr id="3" name="Content Placeholder 14">
@@ -6305,8 +6314,8 @@
           </p:sp>
         </mc:Fallback>
       </mc:AlternateContent>
-      <mc:AlternateContent xmlns:mc="http://schemas.openxmlformats.org/markup-compatibility/2006">
-        <mc:Choice xmlns:a14="http://schemas.microsoft.com/office/drawing/2010/main" Requires="a14">
+      <mc:AlternateContent xmlns:mc="http://schemas.openxmlformats.org/markup-compatibility/2006" xmlns:a14="http://schemas.microsoft.com/office/drawing/2010/main">
+        <mc:Choice Requires="a14">
           <p:sp>
             <p:nvSpPr>
               <p:cNvPr id="4" name="TextBox 3">
@@ -6356,7 +6365,7 @@
             </p:txBody>
           </p:sp>
         </mc:Choice>
-        <mc:Fallback>
+        <mc:Fallback xmlns="">
           <p:sp>
             <p:nvSpPr>
               <p:cNvPr id="4" name="TextBox 3">
@@ -6401,8 +6410,8 @@
           </p:sp>
         </mc:Fallback>
       </mc:AlternateContent>
-      <mc:AlternateContent xmlns:mc="http://schemas.openxmlformats.org/markup-compatibility/2006">
-        <mc:Choice xmlns:a14="http://schemas.microsoft.com/office/drawing/2010/main" Requires="a14">
+      <mc:AlternateContent xmlns:mc="http://schemas.openxmlformats.org/markup-compatibility/2006" xmlns:a14="http://schemas.microsoft.com/office/drawing/2010/main">
+        <mc:Choice Requires="a14">
           <p:sp>
             <p:nvSpPr>
               <p:cNvPr id="5" name="TextBox 4">
@@ -6775,7 +6784,7 @@
             </p:txBody>
           </p:sp>
         </mc:Choice>
-        <mc:Fallback>
+        <mc:Fallback xmlns="">
           <p:sp>
             <p:nvSpPr>
               <p:cNvPr id="5" name="TextBox 4">
@@ -6820,8 +6829,8 @@
           </p:sp>
         </mc:Fallback>
       </mc:AlternateContent>
-      <mc:AlternateContent xmlns:mc="http://schemas.openxmlformats.org/markup-compatibility/2006">
-        <mc:Choice xmlns:a14="http://schemas.microsoft.com/office/drawing/2010/main" Requires="a14">
+      <mc:AlternateContent xmlns:mc="http://schemas.openxmlformats.org/markup-compatibility/2006" xmlns:a14="http://schemas.microsoft.com/office/drawing/2010/main">
+        <mc:Choice Requires="a14">
           <p:sp>
             <p:nvSpPr>
               <p:cNvPr id="6" name="TextBox 5">
@@ -6850,6 +6859,7 @@
               </a:bodyPr>
               <a:lstStyle/>
               <a:p>
+                <a:pPr/>
                 <a14:m>
                   <m:oMathPara xmlns:m="http://schemas.openxmlformats.org/officeDocument/2006/math">
                     <m:oMathParaPr>
@@ -6881,7 +6891,7 @@
             </p:txBody>
           </p:sp>
         </mc:Choice>
-        <mc:Fallback>
+        <mc:Fallback xmlns="">
           <p:sp>
             <p:nvSpPr>
               <p:cNvPr id="6" name="TextBox 5">
@@ -7139,8 +7149,8 @@
           </a:p>
         </p:txBody>
       </p:sp>
-      <mc:AlternateContent xmlns:mc="http://schemas.openxmlformats.org/markup-compatibility/2006">
-        <mc:Choice xmlns:a14="http://schemas.microsoft.com/office/drawing/2010/main" Requires="a14">
+      <mc:AlternateContent xmlns:mc="http://schemas.openxmlformats.org/markup-compatibility/2006" xmlns:a14="http://schemas.microsoft.com/office/drawing/2010/main">
+        <mc:Choice Requires="a14">
           <p:sp>
             <p:nvSpPr>
               <p:cNvPr id="3" name="Content Placeholder 14">
@@ -7365,7 +7375,7 @@
             </p:txBody>
           </p:sp>
         </mc:Choice>
-        <mc:Fallback>
+        <mc:Fallback xmlns="">
           <p:sp>
             <p:nvSpPr>
               <p:cNvPr id="3" name="Content Placeholder 14">
@@ -7409,8 +7419,8 @@
           </p:sp>
         </mc:Fallback>
       </mc:AlternateContent>
-      <mc:AlternateContent xmlns:mc="http://schemas.openxmlformats.org/markup-compatibility/2006">
-        <mc:Choice xmlns:a14="http://schemas.microsoft.com/office/drawing/2010/main" Requires="a14">
+      <mc:AlternateContent xmlns:mc="http://schemas.openxmlformats.org/markup-compatibility/2006" xmlns:a14="http://schemas.microsoft.com/office/drawing/2010/main">
+        <mc:Choice Requires="a14">
           <p:sp>
             <p:nvSpPr>
               <p:cNvPr id="6" name="TextBox 5">
@@ -7500,7 +7510,7 @@
             </p:txBody>
           </p:sp>
         </mc:Choice>
-        <mc:Fallback>
+        <mc:Fallback xmlns="">
           <p:sp>
             <p:nvSpPr>
               <p:cNvPr id="6" name="TextBox 5">
@@ -7545,8 +7555,8 @@
           </p:sp>
         </mc:Fallback>
       </mc:AlternateContent>
-      <mc:AlternateContent xmlns:mc="http://schemas.openxmlformats.org/markup-compatibility/2006">
-        <mc:Choice xmlns:a14="http://schemas.microsoft.com/office/drawing/2010/main" Requires="a14">
+      <mc:AlternateContent xmlns:mc="http://schemas.openxmlformats.org/markup-compatibility/2006" xmlns:a14="http://schemas.microsoft.com/office/drawing/2010/main">
+        <mc:Choice Requires="a14">
           <p:sp>
             <p:nvSpPr>
               <p:cNvPr id="7" name="TextBox 6">
@@ -7636,7 +7646,7 @@
             </p:txBody>
           </p:sp>
         </mc:Choice>
-        <mc:Fallback>
+        <mc:Fallback xmlns="">
           <p:sp>
             <p:nvSpPr>
               <p:cNvPr id="7" name="TextBox 6">
@@ -7874,8 +7884,8 @@
           </a:p>
         </p:txBody>
       </p:sp>
-      <mc:AlternateContent xmlns:mc="http://schemas.openxmlformats.org/markup-compatibility/2006">
-        <mc:Choice xmlns:a14="http://schemas.microsoft.com/office/drawing/2010/main" Requires="a14">
+      <mc:AlternateContent xmlns:mc="http://schemas.openxmlformats.org/markup-compatibility/2006" xmlns:a14="http://schemas.microsoft.com/office/drawing/2010/main">
+        <mc:Choice Requires="a14">
           <p:sp>
             <p:nvSpPr>
               <p:cNvPr id="3" name="Content Placeholder 14">
@@ -8494,7 +8504,7 @@
             </p:txBody>
           </p:sp>
         </mc:Choice>
-        <mc:Fallback>
+        <mc:Fallback xmlns="">
           <p:sp>
             <p:nvSpPr>
               <p:cNvPr id="3" name="Content Placeholder 14">

</xml_diff>